<commit_message>
Pitch deck: replace template's 'Judges look for' guidance bar with our own bottom-line takeaway per slide
</commit_message>
<xml_diff>
--- a/docs/Lodestar_Brief03_Pitch.pptx
+++ b/docs/Lodestar_Brief03_Pitch.pptx
@@ -3225,7 +3225,7 @@
       </p:sp>
       <p:sp>
         <p:nvSpPr>
-          <p:cNvPr id="24" name="Judges look for text"/>
+          <p:cNvPr id="24" name="Bottom line text"/>
           <p:cNvSpPr txBox="1"/>
           <p:nvPr/>
         </p:nvSpPr>
@@ -3253,7 +3253,7 @@
                   <a:schemeClr val="tx2"/>
                 </a:solidFill>
               </a:rPr>
-              <a:t>Judges look for:  </a:t>
+              <a:t>Bottom line:</a:t>
             </a:r>
             <a:pPr indent="0" marL="0">
               <a:buNone/>
@@ -3264,7 +3264,7 @@
                   <a:schemeClr val="tx1"/>
                 </a:solidFill>
               </a:rPr>
-              <a:t>a large, quantified benefit to the people in the brief, backed by real data and the brief's impact metric.</a:t>
+              <a:t>  On real meters, demand landed inside our range in 5 of 6 site-years, and right-sizing roughly halves the cost of power.</a:t>
             </a:r>
             <a:endParaRPr lang="en-US" sz="1200" dirty="0"/>
           </a:p>
@@ -4207,7 +4207,7 @@
       </p:sp>
       <p:sp>
         <p:nvSpPr>
-          <p:cNvPr id="30" name="Judges look for text"/>
+          <p:cNvPr id="30" name="Bottom line text"/>
           <p:cNvSpPr txBox="1"/>
           <p:nvPr/>
         </p:nvSpPr>
@@ -4235,7 +4235,7 @@
                   <a:schemeClr val="tx2"/>
                 </a:solidFill>
               </a:rPr>
-              <a:t>Judges look for:  </a:t>
+              <a:t>Bottom line:</a:t>
             </a:r>
             <a:pPr indent="0" marL="0">
               <a:buNone/>
@@ -4246,7 +4246,7 @@
                   <a:schemeClr val="tx1"/>
                 </a:solidFill>
               </a:rPr>
-              <a:t>a genuinely new approach that addresses a root cause existing solutions miss, not a copy of what exists.</a:t>
+              <a:t>  A calibrated range, a growth curve and a lender view, validated on meters: none of the open tools we found do all four.</a:t>
             </a:r>
             <a:endParaRPr lang="en-US" sz="1200" dirty="0"/>
           </a:p>
@@ -5271,7 +5271,7 @@
       </p:sp>
       <p:sp>
         <p:nvSpPr>
-          <p:cNvPr id="33" name="Judges look for text"/>
+          <p:cNvPr id="33" name="Bottom line text"/>
           <p:cNvSpPr txBox="1"/>
           <p:nvPr/>
         </p:nvSpPr>
@@ -5299,7 +5299,7 @@
                   <a:schemeClr val="tx2"/>
                 </a:solidFill>
               </a:rPr>
-              <a:t>Judges look for:  </a:t>
+              <a:t>Bottom line:</a:t>
             </a:r>
             <a:pPr indent="0" marL="0">
               <a:buNone/>
@@ -5310,7 +5310,7 @@
                   <a:schemeClr val="tx1"/>
                 </a:solidFill>
               </a:rPr>
-              <a:t>a solution that pays for itself, is affordable to the lowest-income users, is maintainable locally, and lowers environmental impact.</a:t>
+              <a:t>  Free for villagers, under a second of compute per forecast, and self-funding at about 200 paid reports a year.</a:t>
             </a:r>
             <a:endParaRPr lang="en-US" sz="1200" dirty="0"/>
           </a:p>
@@ -6175,7 +6175,7 @@
       </p:sp>
       <p:sp>
         <p:nvSpPr>
-          <p:cNvPr id="29" name="Judges look for text"/>
+          <p:cNvPr id="29" name="Bottom line text"/>
           <p:cNvSpPr txBox="1"/>
           <p:nvPr/>
         </p:nvSpPr>
@@ -6203,7 +6203,7 @@
                   <a:schemeClr val="tx2"/>
                 </a:solidFill>
               </a:rPr>
-              <a:t>Judges look for:  </a:t>
+              <a:t>Bottom line:</a:t>
             </a:r>
             <a:pPr indent="0" marL="0">
               <a:buNone/>
@@ -6214,7 +6214,7 @@
                   <a:schemeClr val="tx1"/>
                 </a:solidFill>
               </a:rPr>
-              <a:t>a working prototype on real or realistic data, a clear path to a pilot, and a plan to replicate with costs that fall at scale.</a:t>
+              <a:t>  Live today on real data; the next step is a 10-site pilot with developers bidding into Nigeria's DARES programme.</a:t>
             </a:r>
             <a:endParaRPr lang="en-US" sz="1200" dirty="0"/>
           </a:p>

</xml_diff>

<commit_message>
README: links table, results at a glance, Mermaid architecture, evidence, personas and unit economics, run instructions for macOS/Linux/Windows, project structure, data and software licences, AI disclosure; MIT license; logo on deck title slide; README images
</commit_message>
<xml_diff>
--- a/docs/Lodestar_Brief03_Pitch.pptx
+++ b/docs/Lodestar_Brief03_Pitch.pptx
@@ -2486,6 +2486,30 @@
           </a:p>
         </p:txBody>
       </p:sp>
+      <p:pic>
+        <p:nvPicPr>
+          <p:cNvPr id="27" name="Lodestar logo" descr="Lodestar logo: a guiding star over a forecast band"/>
+          <p:cNvPicPr>
+            <a:picLocks noChangeAspect="1"/>
+          </p:cNvPicPr>
+          <p:nvPr/>
+        </p:nvPicPr>
+        <p:blipFill>
+          <a:blip r:embed="rId3"/>
+          <a:stretch>
+            <a:fillRect/>
+          </a:stretch>
+        </p:blipFill>
+        <p:spPr>
+          <a:xfrm>
+            <a:off x="640080" y="1143000"/>
+            <a:ext cx="731520" cy="731520"/>
+          </a:xfrm>
+          <a:prstGeom prst="rect">
+            <a:avLst/>
+          </a:prstGeom>
+        </p:spPr>
+      </p:pic>
     </p:spTree>
   </p:cSld>
   <p:clrMapOvr>

</xml_diff>

<commit_message>
Pitch deck: problem and solution as slide titles, plain-language range, who pays and market, partner benefits and cost to scale
</commit_message>
<xml_diff>
--- a/docs/Lodestar_Brief03_Pitch.pptx
+++ b/docs/Lodestar_Brief03_Pitch.pptx
@@ -527,7 +527,7 @@
           <a:lstStyle/>
           <a:p>
             <a:r>
-              <a:t>Title (about 20 seconds). I'm Tushar, team Lodestar, Brief 03: predict mini-grid demand before building. Lodestar gives mini-grid developers and their lenders a demand forecast with a bankable range, from open data, before anyone builds. Each following slide answers one judging criterion.</a:t>
+              <a:t>Title. I'm Tushar, team Lodestar, Brief 03. Lodestar tells mini-grid developers and their lenders how much power a village will use, as a range they can bank on, before anyone builds.</a:t>
             </a:r>
           </a:p>
         </p:txBody>
@@ -613,7 +613,7 @@
           <a:lstStyle/>
           <a:p>
             <a:r>
-              <a:t>Impact (about 1 minute). 217,000 mini-grids are needed for 490 million people, and every one is sized on a guess: surveys miss individual demand by 65%. We forecast two real metered village mini-grids in DR Congo from open data only, without their meters: actual demand fell inside our P90-P10 range in 5 of 6 site-years. Replaying that real demand, a desk estimate would have oversized one site by 37%; our build-at-P50-then-expand plan by 6%. Right-sizing on P50 instead of the optimistic case cuts the cost of power by about half.</a:t>
+              <a:t>Impact. 490 million people need 217,000 mini-grids, and every one is sized on a guess: surveys miss what a customer uses by 65%. Too big and tariffs price villagers out; too small and evenings go dark. On two real metered mini-grids in DR Congo, forecast without their meters, real demand landed inside our range in 5 of 6 years. A desk estimate oversized one site by 37%; our plan by 6%. Building for likely demand instead of the optimistic case roughly halves the cost of power.</a:t>
             </a:r>
           </a:p>
         </p:txBody>
@@ -699,7 +699,7 @@
           <a:lstStyle/>
           <a:p>
             <a:r>
-              <a:t>Innovation (about 1 minute). Today a developer gets one day-one number. We borrow P50/P90 energy-yield reports from solar project finance and apply them to demand: connections times consumption, month by month, as a calibrated range. Two more ideas from other industries: a Demand Bureau where operators share meter aggregates like banks share credit data, and a public ledger that registers every forecast before the site is built, like weather-forecast verification.</a:t>
+              <a:t>Innovation. Today a developer gets one number. We give a probabilistic range, as solar finance does for sunshine: a safe level demand beats 9 times in 10, the likely level, and the upside, month by month for five years. Click a village; satellite buildings and OpenStreetMap count customers; 20,000 scenarios give the range; then size the system and stress-test the loan. Operators' meters sharpen it.</a:t>
             </a:r>
           </a:p>
         </p:txBody>
@@ -785,7 +785,7 @@
           <a:lstStyle/>
           <a:p>
             <a:r>
-              <a:t>Sustainability (about 1 minute). Households never pay. Our first customers are developers bidding into results-based-financing programmes like Nigeria's DARES: their head is most on fire and they own the meters. They pay $300 per bankable report; financing programmes subscribe for portfolio screening; lenders follow once our track record builds. Running cost is near zero: open data, under a second of compute per forecast, so about 200 reports a year covers a two-person team. Environmentally, right-sizing avoids stranded panels and batteries, and backup diesel when systems are too small.</a:t>
+              <a:t>Sustainability. Villagers never pay. Developers pay $300 per site report, 0.05% of a mini-grid; funders pay $12k a year to screen portfolios; lenders follow later. Running costs are about $60k a year, so 3 funder subscriptions and about 80 reports break even: 6 to 8 customers. The market: 6,116 sites planned by AMDA members, 1,000+ in Nigeria's DARES alone, 217,000 needed by 2030. Right-sizing also avoids stranded panels and diesel.</a:t>
             </a:r>
           </a:p>
         </p:txBody>
@@ -871,7 +871,7 @@
           <a:lstStyle/>
           <a:p>
             <a:r>
-              <a:t>Feasibility and scalability (about 1 minute), then close. It is live at lodestar-utfz.onrender.com with 20 villages in Nigeria, Kenya and DR Congo, a lender memo, a HOMER load export, SMS and USSD access, and a public track record. Honest risk: only three public metered sites exist, so the first step is backtesting operators' historical meters. Path: 10 pre-registered sites with developers bidding into DARES, then one RBF programme, then five countries. Our ask: 2-3 operators to share meter data and one RBF programme as pilot partner. Lodestar makes demand bankable, so the next 200,000 mini-grids get built at the right size.</a:t>
+              <a:t>Feasibility and scale. Lodestar is live, tested on real meters, and exports to HOMER. The risk is few public meters, so we test on operators' data first. Pilot: 10 sites with DARES developers in Nigeria, then one funder and Kenya, then 5 countries at about $30k a year each. Our ask: 2 to 3 operators' meter data and one RBF programme. In return they get tighter forecasts, which means cheaper debt, peer benchmarks and free reports.</a:t>
             </a:r>
           </a:p>
         </p:txBody>
@@ -2654,7 +2654,7 @@
                 <a:ea typeface="Cambria" pitchFamily="34" charset="-122"/>
                 <a:cs typeface="Cambria" pitchFamily="34" charset="-120"/>
               </a:rPr>
-              <a:t>Villages get mini-grids sized to real demand</a:t>
+              <a:t>Every mini-grid is sized on a guess about demand</a:t>
             </a:r>
             <a:endParaRPr lang="en-US" sz="3600" dirty="0"/>
           </a:p>
@@ -2800,7 +2800,7 @@
                   <a:schemeClr val="tx1"/>
                 </a:solidFill>
               </a:rPr>
-              <a:t>490 million people need the 217,000 mini-grids still to be built (ESMAP). Each is sized before a single customer exists, so developers guess demand: oversize and tariffs price villagers out; undersize and they get evening brownouts.</a:t>
+              <a:t>490 million people need the 217,000 mini-grids still to be built (ESMAP). Each is sized before anyone connects. Too big, and tariffs price villagers out. Too small, and evenings go dark.</a:t>
             </a:r>
             <a:endParaRPr lang="en-US" sz="1600" dirty="0"/>
           </a:p>
@@ -2957,7 +2957,7 @@
                   <a:schemeClr val="tx1"/>
                 </a:solidFill>
               </a:rPr>
-              <a:t>site-years of real metered demand inside our range, forecast from open data with no site meters (DR Congo)</a:t>
+              <a:t>years where real metered demand landed inside our forecast range (DR Congo, forecast without the site's meters)</a:t>
             </a:r>
             <a:endParaRPr lang="en-US" sz="1400" dirty="0"/>
           </a:p>
@@ -3086,7 +3086,7 @@
                   <a:schemeClr val="tx1"/>
                 </a:solidFill>
               </a:rPr>
-              <a:t>year-3 oversizing at a metered site: desk estimate vs Lodestar plan (72% less mismatch)</a:t>
+              <a:t>oversizing at a real site: today's desk estimate vs Lodestar's plan</a:t>
             </a:r>
             <a:endParaRPr lang="en-US" sz="1400" dirty="0"/>
           </a:p>
@@ -3215,7 +3215,7 @@
                   <a:schemeClr val="tx1"/>
                 </a:solidFill>
               </a:rPr>
-              <a:t>cost of power when sized on P50 instead of the optimistic case (avg. of 20 villages)</a:t>
+              <a:t>cost of power when built for likely demand, not the optimistic case (20 villages)</a:t>
             </a:r>
             <a:endParaRPr lang="en-US" sz="1400" dirty="0"/>
           </a:p>
@@ -3288,7 +3288,7 @@
                   <a:schemeClr val="tx1"/>
                 </a:solidFill>
               </a:rPr>
-              <a:t>  On real meters, demand landed inside our range in 5 of 6 site-years, and right-sizing roughly halves the cost of power.</a:t>
+              <a:t>  Tested on real meters: demand landed in our range 5 of 6 times, and right-sizing roughly halves the cost of power.</a:t>
             </a:r>
             <a:endParaRPr lang="en-US" sz="1200" dirty="0"/>
           </a:p>
@@ -3483,7 +3483,7 @@
                 <a:ea typeface="Cambria" pitchFamily="34" charset="-122"/>
                 <a:cs typeface="Cambria" pitchFamily="34" charset="-120"/>
               </a:rPr>
-              <a:t>A P90 for demand, borrowed from solar finance</a:t>
+              <a:t>We forecast demand as a range lenders can bank on</a:t>
             </a:r>
             <a:endParaRPr lang="en-US" sz="3600" dirty="0"/>
           </a:p>
@@ -3581,7 +3581,7 @@
                   <a:schemeClr val="tx1"/>
                 </a:solidFill>
               </a:rPr>
-              <a:t>Surveys or flat benchmarks give one day-one number: no range, no growth, never checked against meters. Lenders cannot price a guess.</a:t>
+              <a:t>One day-one number from a survey or benchmark: no range, no growth, never checked against meters.</a:t>
             </a:r>
             <a:endParaRPr lang="en-US" sz="1500" dirty="0"/>
           </a:p>
@@ -3679,7 +3679,7 @@
                   <a:schemeClr val="bg1"/>
                 </a:solidFill>
               </a:rPr>
-              <a:t>We forecast connections × consumption month by month with a calibrated P90/P50/P10 range, like a solar yield report, validated on real meters.</a:t>
+              <a:t>A probabilistic range, month by month: a safe level demand beats 9 times in 10, the likely level, and the upside.</a:t>
             </a:r>
             <a:endParaRPr lang="en-US" sz="1500" dirty="0"/>
           </a:p>
@@ -3825,7 +3825,7 @@
                   <a:schemeClr val="tx1"/>
                 </a:solidFill>
               </a:rPr>
-              <a:t>No defensible demand number before building, so sites are mis-sized or never financed.</a:t>
+              <a:t>No trusted demand number before building, so sites are mis-sized or never financed.</a:t>
             </a:r>
             <a:endParaRPr lang="en-US" sz="1500" dirty="0"/>
           </a:p>
@@ -3957,7 +3957,7 @@
                   <a:schemeClr val="tx1"/>
                 </a:solidFill>
               </a:rPr>
-              <a:t>Click any village: building footprints and OpenStreetMap give customers and anchors</a:t>
+              <a:t>Click a village: satellite buildings and OpenStreetMap count customers</a:t>
             </a:r>
             <a:endParaRPr lang="en-US" sz="1500" dirty="0"/>
           </a:p>
@@ -4077,7 +4077,7 @@
                   <a:schemeClr val="tx1"/>
                 </a:solidFill>
               </a:rPr>
-              <a:t>20,000 growth scenarios give P90/P50/P10 for 5 years, explained in plain words</a:t>
+              <a:t>20,000 growth scenarios give a five-year range, in plain words</a:t>
             </a:r>
             <a:endParaRPr lang="en-US" sz="1500" dirty="0"/>
           </a:p>
@@ -4197,7 +4197,7 @@
                   <a:schemeClr val="tx1"/>
                 </a:solidFill>
               </a:rPr>
-              <a:t>Size the system, stress-test the loan; shared meters sharpen it (Demand Bureau)</a:t>
+              <a:t>Size the system, stress-test the loan; operators' meters sharpen it</a:t>
             </a:r>
             <a:endParaRPr lang="en-US" sz="1500" dirty="0"/>
           </a:p>
@@ -4270,7 +4270,7 @@
                   <a:schemeClr val="tx1"/>
                 </a:solidFill>
               </a:rPr>
-              <a:t>  A calibrated range, a growth curve and a lender view, validated on meters: none of the open tools we found do all four.</a:t>
+              <a:t>  A range instead of a guess, with growth over time and a lender view, tested on real meters.</a:t>
             </a:r>
             <a:endParaRPr lang="en-US" sz="1200" dirty="0"/>
           </a:p>
@@ -4465,7 +4465,7 @@
                 <a:ea typeface="Cambria" pitchFamily="34" charset="-122"/>
                 <a:cs typeface="Cambria" pitchFamily="34" charset="-120"/>
               </a:rPr>
-              <a:t>Free to villages, pays for itself at scale</a:t>
+              <a:t>Villagers pay nothing; developers and funders do</a:t>
             </a:r>
             <a:endParaRPr lang="en-US" sz="3600" dirty="0"/>
           </a:p>
@@ -4566,7 +4566,7 @@
                 <a:ea typeface="Cambria" pitchFamily="34" charset="-122"/>
                 <a:cs typeface="Cambria" pitchFamily="34" charset="-120"/>
               </a:rPr>
-              <a:t>$0 / month</a:t>
+              <a:t>$0</a:t>
             </a:r>
             <a:endParaRPr lang="en-US" sz="3200" dirty="0"/>
           </a:p>
@@ -4602,7 +4602,7 @@
                   <a:schemeClr val="accent4"/>
                 </a:solidFill>
               </a:rPr>
-              <a:t>for households. Developers pay $300 per site report: 0.05% of a ~$585k mini-grid.</a:t>
+              <a:t>for households. A developer pays $300 per site report: 0.05% of a ~$585k mini-grid.</a:t>
             </a:r>
             <a:endParaRPr lang="en-US" sz="1400" dirty="0"/>
           </a:p>
@@ -4638,7 +4638,7 @@
                   <a:schemeClr val="accent4"/>
                 </a:solidFill>
               </a:rPr>
-              <a:t>PAYBACK</a:t>
+              <a:t>BREAK-EVEN</a:t>
             </a:r>
             <a:endParaRPr lang="en-US" sz="1200" dirty="0"/>
           </a:p>
@@ -4677,7 +4677,7 @@
                 <a:ea typeface="Cambria" pitchFamily="34" charset="-122"/>
                 <a:cs typeface="Cambria" pitchFamily="34" charset="-120"/>
               </a:rPr>
-              <a:t>~200 reports/yr</a:t>
+              <a:t>6–8 customers</a:t>
             </a:r>
             <a:endParaRPr lang="en-US" sz="2400" dirty="0"/>
           </a:p>
@@ -4823,7 +4823,7 @@
                   <a:schemeClr val="tx1"/>
                 </a:solidFill>
               </a:rPr>
-              <a:t>First: developers bidding into results-based financing, per report. Next: RBF programmes, $12k/yr screening. Later: lenders.</a:t>
+              <a:t>Developers: $300 per site report. Funders (RBF programmes, DFIs): $12k/yr to screen portfolios. Lenders: later, per loan file.</a:t>
             </a:r>
             <a:endParaRPr lang="en-US" sz="1400" dirty="0"/>
           </a:p>
@@ -4969,7 +4969,7 @@
                   <a:schemeClr val="tx1"/>
                 </a:solidFill>
               </a:rPr>
-              <a:t>Open data, under 1 CPU-s per forecast. Break-even ~200 reports/yr: 3% of 6,116 planned sites (AMDA). No grant to run.</a:t>
+              <a:t>Costs ~$60k/yr (two analysts, one server). Covered by 3 funder subscriptions + ~80 reports, e.g. 3–5 developers.</a:t>
             </a:r>
             <a:endParaRPr lang="en-US" sz="1400" dirty="0"/>
           </a:p>
@@ -5079,7 +5079,7 @@
                   <a:schemeClr val="accent1"/>
                 </a:solidFill>
               </a:rPr>
-              <a:t>WHO KEEPS IT RUNNING</a:t>
+              <a:t>MARKET</a:t>
             </a:r>
             <a:endParaRPr lang="en-US" sz="1200" dirty="0"/>
           </a:p>
@@ -5115,7 +5115,7 @@
                   <a:schemeClr val="tx1"/>
                 </a:solidFill>
               </a:rPr>
-              <a:t>Two analysts in Nairobi or Lagos; Python on a laptop, no API keys; quarterly re-fit on Bureau meter data.</a:t>
+              <a:t>AMDA members plan 6,116 sites (≈$1.8M in reports). Nigeria's DARES alone: 1,000+. Needed by 2030: 217,000.</a:t>
             </a:r>
             <a:endParaRPr lang="en-US" sz="1400" dirty="0"/>
           </a:p>
@@ -5261,7 +5261,7 @@
                   <a:schemeClr val="tx1"/>
                 </a:solidFill>
               </a:rPr>
-              <a:t>No stranded panels and batteries (desk plan oversized 61 kWp at one site, ours 9) and less backup diesel.</a:t>
+              <a:t>No stranded panels and batteries (desk plan oversized a real site by 61 kWp, ours by 9) and less backup diesel.</a:t>
             </a:r>
             <a:endParaRPr lang="en-US" sz="1400" dirty="0"/>
           </a:p>
@@ -5334,7 +5334,7 @@
                   <a:schemeClr val="tx1"/>
                 </a:solidFill>
               </a:rPr>
-              <a:t>  Free for villagers, under a second of compute per forecast, and self-funding at about 200 paid reports a year.</a:t>
+              <a:t>  Villagers pay nothing. 6–8 paying customers cover costs, in a pipeline of thousands of planned sites.</a:t>
             </a:r>
             <a:endParaRPr lang="en-US" sz="1200" dirty="0"/>
           </a:p>
@@ -5529,7 +5529,7 @@
                 <a:ea typeface="Cambria" pitchFamily="34" charset="-122"/>
                 <a:cs typeface="Cambria" pitchFamily="34" charset="-120"/>
               </a:rPr>
-              <a:t>Live today, validated on real meters</a:t>
+              <a:t>Live and tested; next, a 10-site pilot in Nigeria</a:t>
             </a:r>
             <a:endParaRPr lang="en-US" sz="3600" dirty="0"/>
           </a:p>
@@ -5605,7 +5605,7 @@
                   <a:schemeClr val="tx1"/>
                 </a:solidFill>
               </a:rPr>
-              <a:t>DRC meters: demand in range 5 of 6 site-years</a:t>
+              <a:t>Real meters: demand in range 5 of 6 years</a:t>
             </a:r>
             <a:endParaRPr lang="en-US" sz="1400" dirty="0"/>
           </a:p>
@@ -5623,7 +5623,7 @@
                   <a:schemeClr val="tx1"/>
                 </a:solidFill>
               </a:rPr>
-              <a:t>HOMER export; open licences; aggregate-only data</a:t>
+              <a:t>Exports to HOMER; open data and licences</a:t>
             </a:r>
             <a:endParaRPr lang="en-US" sz="1400" dirty="0"/>
           </a:p>
@@ -5641,7 +5641,7 @@
                   <a:schemeClr val="tx1"/>
                 </a:solidFill>
               </a:rPr>
-              <a:t>Risk: 3 metered sites → backtest operators first</a:t>
+              <a:t>Risk: few public meters → backtest operators first</a:t>
             </a:r>
             <a:endParaRPr lang="en-US" sz="1400" dirty="0"/>
           </a:p>
@@ -5775,7 +5775,7 @@
                   <a:schemeClr val="tx1"/>
                 </a:solidFill>
               </a:rPr>
-              <a:t>Nigeria: 10 sites with developers bidding into DARES</a:t>
+              <a:t>Nigeria: 10 sites with DARES developers</a:t>
             </a:r>
             <a:endParaRPr lang="en-US" sz="1400" dirty="0"/>
           </a:p>
@@ -5897,7 +5897,7 @@
                   <a:schemeClr val="tx1"/>
                 </a:solidFill>
               </a:rPr>
-              <a:t>Score on meters; one RBF programme; Kenya next</a:t>
+              <a:t>Score on meters; one funder; Kenya next</a:t>
             </a:r>
             <a:endParaRPr lang="en-US" sz="1400" dirty="0"/>
           </a:p>
@@ -6019,7 +6019,7 @@
                   <a:schemeClr val="bg1"/>
                 </a:solidFill>
               </a:rPr>
-              <a:t>5 countries via the Bureau; ~1 CPU-s per site</a:t>
+              <a:t>5 countries: ~$30k/yr per country (est.), compute ~free</a:t>
             </a:r>
             <a:endParaRPr lang="en-US" sz="1400" dirty="0"/>
           </a:p>
@@ -6165,7 +6165,7 @@
                   <a:schemeClr val="bg1"/>
                 </a:solidFill>
               </a:rPr>
-              <a:t>2–3 mini-grid operators to share historical meter data, and one RBF programme as pilot partner. Live: lodestar-utfz.onrender.com</a:t>
+              <a:t>2–3 operators' past meter data, and one RBF programme as pilot partner. They get back: tighter forecasts (cheaper debt), peer benchmarks, free reports.</a:t>
             </a:r>
             <a:endParaRPr lang="en-US" sz="1600" dirty="0"/>
           </a:p>
@@ -6238,7 +6238,7 @@
                   <a:schemeClr val="tx1"/>
                 </a:solidFill>
               </a:rPr>
-              <a:t>  Live today on real data; the next step is a 10-site pilot with developers bidding into Nigeria's DARES programme.</a:t>
+              <a:t>  Live at lodestar-utfz.onrender.com. Partners who share meter data get tighter forecasts and cheaper debt in return.</a:t>
             </a:r>
             <a:endParaRPr lang="en-US" sz="1200" dirty="0"/>
           </a:p>

</xml_diff>